<commit_message>
chore: update pitch deck (Diamond tier, Discord) + gitignore build artifacts
Co-Authored-By: Claude Opus 4.6 <noreply@anthropic.com>
</commit_message>
<xml_diff>
--- a/DEEP_PULSE_PITCH_DECK_2026.pptx
+++ b/DEEP_PULSE_PITCH_DECK_2026.pptx
@@ -8906,7 +8906,8 @@
               </a:defRPr>
             </a:pPr>
             <a:r>
-              <a:t>DEEP Score v2</a:t>
+              <a:t>DEEP Score v2
+Discord → Hub pipeline</a:t>
             </a:r>
           </a:p>
         </p:txBody>
@@ -15063,7 +15064,7 @@
               </a:defRPr>
             </a:pPr>
             <a:r>
-              <a:t>Platinum</a:t>
+              <a:t>Diamond</a:t>
             </a:r>
           </a:p>
         </p:txBody>

</xml_diff>

<commit_message>
Update docs: 17→19 screens, add Push Notif Ads + DOOH + hub lifecycle
- VIDEO_PROMPT.md: add scenes for Push Notif Ads, DOOH, hub lifecycle
- MANIFEST.md: update to 19 screens, add missing files, update features
- PowerPoint: fix screen count 17→19 on slides 13 + 14

Co-Authored-By: Claude Opus 4.6 <noreply@anthropic.com>
</commit_message>
<xml_diff>
--- a/DEEP_PULSE_PITCH_DECK_2026.pptx
+++ b/DEEP_PULSE_PITCH_DECK_2026.pptx
@@ -8762,7 +8762,7 @@
               </a:defRPr>
             </a:pPr>
             <a:r>
-              <a:t>17 screens built</a:t>
+              <a:t>19 screens built</a:t>
             </a:r>
           </a:p>
         </p:txBody>
@@ -10453,7 +10453,7 @@
               </a:defRPr>
             </a:pPr>
             <a:r>
-              <a:t>17</a:t>
+              <a:t>19</a:t>
             </a:r>
           </a:p>
         </p:txBody>

</xml_diff>